<commit_message>
Paiements et relances WhatsApp accessibles aux agents d'accueil
L'agent peut désormais consulter les paiements, réimprimer un reçu et
envoyer les relances (renouvellement, anniversaire). Restent réservés :
tableau de bord et statistiques (gérant), exports Excel, tarifs, comptes
employés et paramètres (super administrateur). Formation et README mis à jour.

Co-Authored-By: Claude Fable 5 <noreply@anthropic.com>
</commit_message>
<xml_diff>
--- a/formation/Didikids_Parc_Formation_Employes.pptx
+++ b/formation/Didikids_Parc_Formation_Employes.pptx
@@ -7408,8 +7408,8 @@
         </p:nvSpPr>
         <p:spPr>
           <a:xfrm>
-            <a:off x="960120" y="3191256"/>
-            <a:ext cx="219456" cy="219456"/>
+            <a:off x="960120" y="3072384"/>
+            <a:ext cx="201168" cy="201168"/>
           </a:xfrm>
           <a:prstGeom prst="ellipse">
             <a:avLst/>
@@ -7461,8 +7461,8 @@
         </p:nvSpPr>
         <p:spPr>
           <a:xfrm>
-            <a:off x="1325880" y="3136392"/>
-            <a:ext cx="2606040" cy="548640"/>
+            <a:off x="1307592" y="2999232"/>
+            <a:ext cx="2624328" cy="566928"/>
           </a:xfrm>
           <a:prstGeom prst="rect">
             <a:avLst/>
@@ -7484,7 +7484,7 @@
               </a:spcAft>
             </a:pPr>
             <a:r>
-              <a:rPr sz="1400" b="0">
+              <a:rPr sz="1350" b="0">
                 <a:solidFill>
                   <a:srgbClr val="2D3A2E"/>
                 </a:solidFill>
@@ -7503,8 +7503,8 @@
         </p:nvSpPr>
         <p:spPr>
           <a:xfrm>
-            <a:off x="960120" y="3776472"/>
-            <a:ext cx="219456" cy="219456"/>
+            <a:off x="960120" y="3584448"/>
+            <a:ext cx="201168" cy="201168"/>
           </a:xfrm>
           <a:prstGeom prst="ellipse">
             <a:avLst/>
@@ -7556,8 +7556,8 @@
         </p:nvSpPr>
         <p:spPr>
           <a:xfrm>
-            <a:off x="1325880" y="3721608"/>
-            <a:ext cx="2606040" cy="548640"/>
+            <a:off x="1307592" y="3511296"/>
+            <a:ext cx="2624328" cy="566928"/>
           </a:xfrm>
           <a:prstGeom prst="rect">
             <a:avLst/>
@@ -7579,7 +7579,7 @@
               </a:spcAft>
             </a:pPr>
             <a:r>
-              <a:rPr sz="1400" b="0">
+              <a:rPr sz="1350" b="0">
                 <a:solidFill>
                   <a:srgbClr val="2D3A2E"/>
                 </a:solidFill>
@@ -7598,8 +7598,8 @@
         </p:nvSpPr>
         <p:spPr>
           <a:xfrm>
-            <a:off x="960120" y="4361688"/>
-            <a:ext cx="219456" cy="219456"/>
+            <a:off x="960120" y="4096511"/>
+            <a:ext cx="201168" cy="201168"/>
           </a:xfrm>
           <a:prstGeom prst="ellipse">
             <a:avLst/>
@@ -7651,8 +7651,8 @@
         </p:nvSpPr>
         <p:spPr>
           <a:xfrm>
-            <a:off x="1325880" y="4306824"/>
-            <a:ext cx="2606040" cy="548640"/>
+            <a:off x="1307592" y="4023360"/>
+            <a:ext cx="2624328" cy="566928"/>
           </a:xfrm>
           <a:prstGeom prst="rect">
             <a:avLst/>
@@ -7674,7 +7674,7 @@
               </a:spcAft>
             </a:pPr>
             <a:r>
-              <a:rPr sz="1400" b="0">
+              <a:rPr sz="1350" b="0">
                 <a:solidFill>
                   <a:srgbClr val="2D3A2E"/>
                 </a:solidFill>
@@ -7693,8 +7693,8 @@
         </p:nvSpPr>
         <p:spPr>
           <a:xfrm>
-            <a:off x="960120" y="4946903"/>
-            <a:ext cx="219456" cy="219456"/>
+            <a:off x="960120" y="4608576"/>
+            <a:ext cx="201168" cy="201168"/>
           </a:xfrm>
           <a:prstGeom prst="ellipse">
             <a:avLst/>
@@ -7746,8 +7746,8 @@
         </p:nvSpPr>
         <p:spPr>
           <a:xfrm>
-            <a:off x="1325880" y="4892040"/>
-            <a:ext cx="2606040" cy="548640"/>
+            <a:off x="1307592" y="4535424"/>
+            <a:ext cx="2624328" cy="566928"/>
           </a:xfrm>
           <a:prstGeom prst="rect">
             <a:avLst/>
@@ -7769,7 +7769,7 @@
               </a:spcAft>
             </a:pPr>
             <a:r>
-              <a:rPr sz="1400" b="0">
+              <a:rPr sz="1350" b="0">
                 <a:solidFill>
                   <a:srgbClr val="2D3A2E"/>
                 </a:solidFill>
@@ -7788,8 +7788,8 @@
         </p:nvSpPr>
         <p:spPr>
           <a:xfrm>
-            <a:off x="960120" y="5532119"/>
-            <a:ext cx="219456" cy="219456"/>
+            <a:off x="960120" y="5120640"/>
+            <a:ext cx="201168" cy="201168"/>
           </a:xfrm>
           <a:prstGeom prst="ellipse">
             <a:avLst/>
@@ -7841,8 +7841,8 @@
         </p:nvSpPr>
         <p:spPr>
           <a:xfrm>
-            <a:off x="1325880" y="5477255"/>
-            <a:ext cx="2606040" cy="548640"/>
+            <a:off x="1307592" y="5047488"/>
+            <a:ext cx="2624328" cy="566928"/>
           </a:xfrm>
           <a:prstGeom prst="rect">
             <a:avLst/>
@@ -7864,20 +7864,115 @@
               </a:spcAft>
             </a:pPr>
             <a:r>
-              <a:rPr sz="1400" b="0">
+              <a:rPr sz="1350" b="0">
                 <a:solidFill>
                   <a:srgbClr val="2D3A2E"/>
                 </a:solidFill>
                 <a:latin typeface="Calibri"/>
               </a:rPr>
-              <a:t>Voir les passages du jour</a:t>
-            </a:r>
-          </a:p>
-        </p:txBody>
-      </p:sp>
-      <p:sp>
-        <p:nvSpPr>
-          <p:cNvPr id="18" name="Rounded Rectangle 17"/>
+              <a:t>Voir les paiements, réimprimer un reçu</a:t>
+            </a:r>
+          </a:p>
+        </p:txBody>
+      </p:sp>
+      <p:sp>
+        <p:nvSpPr>
+          <p:cNvPr id="18" name="Oval 17"/>
+          <p:cNvSpPr/>
+          <p:nvPr/>
+        </p:nvSpPr>
+        <p:spPr>
+          <a:xfrm>
+            <a:off x="960120" y="5632704"/>
+            <a:ext cx="201168" cy="201168"/>
+          </a:xfrm>
+          <a:prstGeom prst="ellipse">
+            <a:avLst/>
+          </a:prstGeom>
+          <a:solidFill>
+            <a:srgbClr val="4CAF50"/>
+          </a:solidFill>
+          <a:ln>
+            <a:noFill/>
+          </a:ln>
+          <a:effectLst/>
+        </p:spPr>
+        <p:style>
+          <a:lnRef idx="1">
+            <a:schemeClr val="accent1"/>
+          </a:lnRef>
+          <a:fillRef idx="3">
+            <a:schemeClr val="accent1"/>
+          </a:fillRef>
+          <a:effectRef idx="2">
+            <a:schemeClr val="accent1"/>
+          </a:effectRef>
+          <a:fontRef idx="minor">
+            <a:schemeClr val="lt1"/>
+          </a:fontRef>
+        </p:style>
+        <p:txBody>
+          <a:bodyPr rtlCol="0" anchor="ctr" lIns="0" rIns="0" tIns="0" bIns="0"/>
+          <a:lstStyle/>
+          <a:p>
+            <a:pPr algn="ctr"/>
+            <a:r>
+              <a:rPr sz="900" b="1">
+                <a:solidFill>
+                  <a:srgbClr val="FFFFFF"/>
+                </a:solidFill>
+                <a:latin typeface="Calibri"/>
+              </a:rPr>
+              <a:t/>
+            </a:r>
+          </a:p>
+        </p:txBody>
+      </p:sp>
+      <p:sp>
+        <p:nvSpPr>
+          <p:cNvPr id="19" name="TextBox 18"/>
+          <p:cNvSpPr txBox="1"/>
+          <p:nvPr/>
+        </p:nvSpPr>
+        <p:spPr>
+          <a:xfrm>
+            <a:off x="1307592" y="5559552"/>
+            <a:ext cx="2624328" cy="566928"/>
+          </a:xfrm>
+          <a:prstGeom prst="rect">
+            <a:avLst/>
+          </a:prstGeom>
+          <a:noFill/>
+        </p:spPr>
+        <p:txBody>
+          <a:bodyPr wrap="square" lIns="0" rIns="0" tIns="0" bIns="0" anchor="t">
+            <a:spAutoFit/>
+          </a:bodyPr>
+          <a:lstStyle/>
+          <a:p>
+            <a:pPr algn="l">
+              <a:lnSpc>
+                <a:spcPct val="115000"/>
+              </a:lnSpc>
+              <a:spcAft>
+                <a:spcPts val="600"/>
+              </a:spcAft>
+            </a:pPr>
+            <a:r>
+              <a:rPr sz="1350" b="0">
+                <a:solidFill>
+                  <a:srgbClr val="2D3A2E"/>
+                </a:solidFill>
+                <a:latin typeface="Calibri"/>
+              </a:rPr>
+              <a:t>Envoyer les relances WhatsApp</a:t>
+            </a:r>
+          </a:p>
+        </p:txBody>
+      </p:sp>
+      <p:sp>
+        <p:nvSpPr>
+          <p:cNvPr id="20" name="Rounded Rectangle 19"/>
           <p:cNvSpPr/>
           <p:nvPr/>
         </p:nvSpPr>
@@ -7925,7 +8020,7 @@
       </p:sp>
       <p:sp>
         <p:nvSpPr>
-          <p:cNvPr id="19" name="Rounded Rectangle 18"/>
+          <p:cNvPr id="21" name="Rounded Rectangle 20"/>
           <p:cNvSpPr/>
           <p:nvPr/>
         </p:nvSpPr>
@@ -7971,7 +8066,7 @@
       </p:sp>
       <p:sp>
         <p:nvSpPr>
-          <p:cNvPr id="20" name="TextBox 19"/>
+          <p:cNvPr id="22" name="TextBox 21"/>
           <p:cNvSpPr txBox="1"/>
           <p:nvPr/>
         </p:nvSpPr>
@@ -8010,14 +8105,14 @@
       </p:sp>
       <p:sp>
         <p:nvSpPr>
-          <p:cNvPr id="21" name="Oval 20"/>
+          <p:cNvPr id="23" name="Oval 22"/>
           <p:cNvSpPr/>
           <p:nvPr/>
         </p:nvSpPr>
         <p:spPr>
           <a:xfrm>
-            <a:off x="4617720" y="3191256"/>
-            <a:ext cx="219456" cy="219456"/>
+            <a:off x="4617720" y="3072384"/>
+            <a:ext cx="201168" cy="201168"/>
           </a:xfrm>
           <a:prstGeom prst="ellipse">
             <a:avLst/>
@@ -8063,14 +8158,14 @@
       </p:sp>
       <p:sp>
         <p:nvSpPr>
-          <p:cNvPr id="22" name="TextBox 21"/>
+          <p:cNvPr id="24" name="TextBox 23"/>
           <p:cNvSpPr txBox="1"/>
           <p:nvPr/>
         </p:nvSpPr>
         <p:spPr>
           <a:xfrm>
-            <a:off x="4983480" y="3136392"/>
-            <a:ext cx="2606040" cy="548640"/>
+            <a:off x="4965192" y="2999232"/>
+            <a:ext cx="2624328" cy="566928"/>
           </a:xfrm>
           <a:prstGeom prst="rect">
             <a:avLst/>
@@ -8092,7 +8187,7 @@
               </a:spcAft>
             </a:pPr>
             <a:r>
-              <a:rPr sz="1400" b="0">
+              <a:rPr sz="1350" b="0">
                 <a:solidFill>
                   <a:srgbClr val="2D3A2E"/>
                 </a:solidFill>
@@ -8105,14 +8200,14 @@
       </p:sp>
       <p:sp>
         <p:nvSpPr>
-          <p:cNvPr id="23" name="Oval 22"/>
+          <p:cNvPr id="25" name="Oval 24"/>
           <p:cNvSpPr/>
           <p:nvPr/>
         </p:nvSpPr>
         <p:spPr>
           <a:xfrm>
-            <a:off x="4617720" y="3776472"/>
-            <a:ext cx="219456" cy="219456"/>
+            <a:off x="4617720" y="3584448"/>
+            <a:ext cx="201168" cy="201168"/>
           </a:xfrm>
           <a:prstGeom prst="ellipse">
             <a:avLst/>
@@ -8158,14 +8253,14 @@
       </p:sp>
       <p:sp>
         <p:nvSpPr>
-          <p:cNvPr id="24" name="TextBox 23"/>
+          <p:cNvPr id="26" name="TextBox 25"/>
           <p:cNvSpPr txBox="1"/>
           <p:nvPr/>
         </p:nvSpPr>
         <p:spPr>
           <a:xfrm>
-            <a:off x="4983480" y="3721608"/>
-            <a:ext cx="2606040" cy="548640"/>
+            <a:off x="4965192" y="3511296"/>
+            <a:ext cx="2624328" cy="566928"/>
           </a:xfrm>
           <a:prstGeom prst="rect">
             <a:avLst/>
@@ -8187,27 +8282,27 @@
               </a:spcAft>
             </a:pPr>
             <a:r>
-              <a:rPr sz="1400" b="0">
+              <a:rPr sz="1350" b="0">
                 <a:solidFill>
                   <a:srgbClr val="2D3A2E"/>
                 </a:solidFill>
                 <a:latin typeface="Calibri"/>
               </a:rPr>
-              <a:t>Voir les paiements</a:t>
-            </a:r>
-          </a:p>
-        </p:txBody>
-      </p:sp>
-      <p:sp>
-        <p:nvSpPr>
-          <p:cNvPr id="25" name="Oval 24"/>
+              <a:t>Voir le tableau de bord</a:t>
+            </a:r>
+          </a:p>
+        </p:txBody>
+      </p:sp>
+      <p:sp>
+        <p:nvSpPr>
+          <p:cNvPr id="27" name="Oval 26"/>
           <p:cNvSpPr/>
           <p:nvPr/>
         </p:nvSpPr>
         <p:spPr>
           <a:xfrm>
-            <a:off x="4617720" y="4361688"/>
-            <a:ext cx="219456" cy="219456"/>
+            <a:off x="4617720" y="4096511"/>
+            <a:ext cx="201168" cy="201168"/>
           </a:xfrm>
           <a:prstGeom prst="ellipse">
             <a:avLst/>
@@ -8253,14 +8348,14 @@
       </p:sp>
       <p:sp>
         <p:nvSpPr>
-          <p:cNvPr id="26" name="TextBox 25"/>
+          <p:cNvPr id="28" name="TextBox 27"/>
           <p:cNvSpPr txBox="1"/>
           <p:nvPr/>
         </p:nvSpPr>
         <p:spPr>
           <a:xfrm>
-            <a:off x="4983480" y="4306824"/>
-            <a:ext cx="2606040" cy="548640"/>
+            <a:off x="4965192" y="4023360"/>
+            <a:ext cx="2624328" cy="566928"/>
           </a:xfrm>
           <a:prstGeom prst="rect">
             <a:avLst/>
@@ -8282,27 +8377,27 @@
               </a:spcAft>
             </a:pPr>
             <a:r>
-              <a:rPr sz="1400" b="0">
+              <a:rPr sz="1350" b="0">
                 <a:solidFill>
                   <a:srgbClr val="2D3A2E"/>
                 </a:solidFill>
                 <a:latin typeface="Calibri"/>
               </a:rPr>
-              <a:t>Voir le tableau de bord</a:t>
-            </a:r>
-          </a:p>
-        </p:txBody>
-      </p:sp>
-      <p:sp>
-        <p:nvSpPr>
-          <p:cNvPr id="27" name="Oval 26"/>
+              <a:t>Voir les revenus et statistiques</a:t>
+            </a:r>
+          </a:p>
+        </p:txBody>
+      </p:sp>
+      <p:sp>
+        <p:nvSpPr>
+          <p:cNvPr id="29" name="Oval 28"/>
           <p:cNvSpPr/>
           <p:nvPr/>
         </p:nvSpPr>
         <p:spPr>
           <a:xfrm>
-            <a:off x="4617720" y="4946903"/>
-            <a:ext cx="219456" cy="219456"/>
+            <a:off x="4617720" y="4608576"/>
+            <a:ext cx="201168" cy="201168"/>
           </a:xfrm>
           <a:prstGeom prst="ellipse">
             <a:avLst/>
@@ -8348,14 +8443,14 @@
       </p:sp>
       <p:sp>
         <p:nvSpPr>
-          <p:cNvPr id="28" name="TextBox 27"/>
+          <p:cNvPr id="30" name="TextBox 29"/>
           <p:cNvSpPr txBox="1"/>
           <p:nvPr/>
         </p:nvSpPr>
         <p:spPr>
           <a:xfrm>
-            <a:off x="4983480" y="4892040"/>
-            <a:ext cx="2606040" cy="548640"/>
+            <a:off x="4965192" y="4535424"/>
+            <a:ext cx="2624328" cy="566928"/>
           </a:xfrm>
           <a:prstGeom prst="rect">
             <a:avLst/>
@@ -8377,102 +8472,7 @@
               </a:spcAft>
             </a:pPr>
             <a:r>
-              <a:rPr sz="1400" b="0">
-                <a:solidFill>
-                  <a:srgbClr val="2D3A2E"/>
-                </a:solidFill>
-                <a:latin typeface="Calibri"/>
-              </a:rPr>
-              <a:t>Envoyer les relances WhatsApp</a:t>
-            </a:r>
-          </a:p>
-        </p:txBody>
-      </p:sp>
-      <p:sp>
-        <p:nvSpPr>
-          <p:cNvPr id="29" name="Oval 28"/>
-          <p:cNvSpPr/>
-          <p:nvPr/>
-        </p:nvSpPr>
-        <p:spPr>
-          <a:xfrm>
-            <a:off x="4617720" y="5532119"/>
-            <a:ext cx="219456" cy="219456"/>
-          </a:xfrm>
-          <a:prstGeom prst="ellipse">
-            <a:avLst/>
-          </a:prstGeom>
-          <a:solidFill>
-            <a:srgbClr val="F5C518"/>
-          </a:solidFill>
-          <a:ln>
-            <a:noFill/>
-          </a:ln>
-          <a:effectLst/>
-        </p:spPr>
-        <p:style>
-          <a:lnRef idx="1">
-            <a:schemeClr val="accent1"/>
-          </a:lnRef>
-          <a:fillRef idx="3">
-            <a:schemeClr val="accent1"/>
-          </a:fillRef>
-          <a:effectRef idx="2">
-            <a:schemeClr val="accent1"/>
-          </a:effectRef>
-          <a:fontRef idx="minor">
-            <a:schemeClr val="lt1"/>
-          </a:fontRef>
-        </p:style>
-        <p:txBody>
-          <a:bodyPr rtlCol="0" anchor="ctr" lIns="0" rIns="0" tIns="0" bIns="0"/>
-          <a:lstStyle/>
-          <a:p>
-            <a:pPr algn="ctr"/>
-            <a:r>
-              <a:rPr sz="900" b="1">
-                <a:solidFill>
-                  <a:srgbClr val="FFFFFF"/>
-                </a:solidFill>
-                <a:latin typeface="Calibri"/>
-              </a:rPr>
-              <a:t/>
-            </a:r>
-          </a:p>
-        </p:txBody>
-      </p:sp>
-      <p:sp>
-        <p:nvSpPr>
-          <p:cNvPr id="30" name="TextBox 29"/>
-          <p:cNvSpPr txBox="1"/>
-          <p:nvPr/>
-        </p:nvSpPr>
-        <p:spPr>
-          <a:xfrm>
-            <a:off x="4983480" y="5477255"/>
-            <a:ext cx="2606040" cy="548640"/>
-          </a:xfrm>
-          <a:prstGeom prst="rect">
-            <a:avLst/>
-          </a:prstGeom>
-          <a:noFill/>
-        </p:spPr>
-        <p:txBody>
-          <a:bodyPr wrap="square" lIns="0" rIns="0" tIns="0" bIns="0" anchor="t">
-            <a:spAutoFit/>
-          </a:bodyPr>
-          <a:lstStyle/>
-          <a:p>
-            <a:pPr algn="l">
-              <a:lnSpc>
-                <a:spcPct val="115000"/>
-              </a:lnSpc>
-              <a:spcAft>
-                <a:spcPts val="600"/>
-              </a:spcAft>
-            </a:pPr>
-            <a:r>
-              <a:rPr sz="1400" b="0">
+              <a:rPr sz="1350" b="0">
                 <a:solidFill>
                   <a:srgbClr val="2D3A2E"/>
                 </a:solidFill>
@@ -8624,8 +8624,8 @@
         </p:nvSpPr>
         <p:spPr>
           <a:xfrm>
-            <a:off x="8275320" y="3191256"/>
-            <a:ext cx="219456" cy="219456"/>
+            <a:off x="8275320" y="3072384"/>
+            <a:ext cx="201168" cy="201168"/>
           </a:xfrm>
           <a:prstGeom prst="ellipse">
             <a:avLst/>
@@ -8677,8 +8677,8 @@
         </p:nvSpPr>
         <p:spPr>
           <a:xfrm>
-            <a:off x="8641080" y="3136392"/>
-            <a:ext cx="2606040" cy="548640"/>
+            <a:off x="8622792" y="2999232"/>
+            <a:ext cx="2624328" cy="566928"/>
           </a:xfrm>
           <a:prstGeom prst="rect">
             <a:avLst/>
@@ -8700,7 +8700,7 @@
               </a:spcAft>
             </a:pPr>
             <a:r>
-              <a:rPr sz="1400" b="0">
+              <a:rPr sz="1350" b="0">
                 <a:solidFill>
                   <a:srgbClr val="2D3A2E"/>
                 </a:solidFill>
@@ -8719,8 +8719,8 @@
         </p:nvSpPr>
         <p:spPr>
           <a:xfrm>
-            <a:off x="8275320" y="3776472"/>
-            <a:ext cx="219456" cy="219456"/>
+            <a:off x="8275320" y="3584448"/>
+            <a:ext cx="201168" cy="201168"/>
           </a:xfrm>
           <a:prstGeom prst="ellipse">
             <a:avLst/>
@@ -8772,8 +8772,8 @@
         </p:nvSpPr>
         <p:spPr>
           <a:xfrm>
-            <a:off x="8641080" y="3721608"/>
-            <a:ext cx="2606040" cy="548640"/>
+            <a:off x="8622792" y="3511296"/>
+            <a:ext cx="2624328" cy="566928"/>
           </a:xfrm>
           <a:prstGeom prst="rect">
             <a:avLst/>
@@ -8795,7 +8795,7 @@
               </a:spcAft>
             </a:pPr>
             <a:r>
-              <a:rPr sz="1400" b="0">
+              <a:rPr sz="1350" b="0">
                 <a:solidFill>
                   <a:srgbClr val="2D3A2E"/>
                 </a:solidFill>
@@ -8814,8 +8814,8 @@
         </p:nvSpPr>
         <p:spPr>
           <a:xfrm>
-            <a:off x="8275320" y="4361688"/>
-            <a:ext cx="219456" cy="219456"/>
+            <a:off x="8275320" y="4096511"/>
+            <a:ext cx="201168" cy="201168"/>
           </a:xfrm>
           <a:prstGeom prst="ellipse">
             <a:avLst/>
@@ -8867,8 +8867,8 @@
         </p:nvSpPr>
         <p:spPr>
           <a:xfrm>
-            <a:off x="8641080" y="4306824"/>
-            <a:ext cx="2606040" cy="548640"/>
+            <a:off x="8622792" y="4023360"/>
+            <a:ext cx="2624328" cy="566928"/>
           </a:xfrm>
           <a:prstGeom prst="rect">
             <a:avLst/>
@@ -8890,7 +8890,7 @@
               </a:spcAft>
             </a:pPr>
             <a:r>
-              <a:rPr sz="1400" b="0">
+              <a:rPr sz="1350" b="0">
                 <a:solidFill>
                   <a:srgbClr val="2D3A2E"/>
                 </a:solidFill>
@@ -8909,8 +8909,8 @@
         </p:nvSpPr>
         <p:spPr>
           <a:xfrm>
-            <a:off x="8275320" y="4946903"/>
-            <a:ext cx="219456" cy="219456"/>
+            <a:off x="8275320" y="4608576"/>
+            <a:ext cx="201168" cy="201168"/>
           </a:xfrm>
           <a:prstGeom prst="ellipse">
             <a:avLst/>
@@ -8962,8 +8962,8 @@
         </p:nvSpPr>
         <p:spPr>
           <a:xfrm>
-            <a:off x="8641080" y="4892040"/>
-            <a:ext cx="2606040" cy="548640"/>
+            <a:off x="8622792" y="4535424"/>
+            <a:ext cx="2624328" cy="566928"/>
           </a:xfrm>
           <a:prstGeom prst="rect">
             <a:avLst/>
@@ -8985,7 +8985,7 @@
               </a:spcAft>
             </a:pPr>
             <a:r>
-              <a:rPr sz="1400" b="0">
+              <a:rPr sz="1350" b="0">
                 <a:solidFill>
                   <a:srgbClr val="2D3A2E"/>
                 </a:solidFill>
@@ -9004,8 +9004,8 @@
         </p:nvSpPr>
         <p:spPr>
           <a:xfrm>
-            <a:off x="8275320" y="5532119"/>
-            <a:ext cx="219456" cy="219456"/>
+            <a:off x="8275320" y="5120640"/>
+            <a:ext cx="201168" cy="201168"/>
           </a:xfrm>
           <a:prstGeom prst="ellipse">
             <a:avLst/>
@@ -9057,8 +9057,8 @@
         </p:nvSpPr>
         <p:spPr>
           <a:xfrm>
-            <a:off x="8641080" y="5477255"/>
-            <a:ext cx="2606040" cy="548640"/>
+            <a:off x="8622792" y="5047488"/>
+            <a:ext cx="2624328" cy="566928"/>
           </a:xfrm>
           <a:prstGeom prst="rect">
             <a:avLst/>
@@ -9080,7 +9080,102 @@
               </a:spcAft>
             </a:pPr>
             <a:r>
-              <a:rPr sz="1400" b="0">
+              <a:rPr sz="1350" b="0">
+                <a:solidFill>
+                  <a:srgbClr val="2D3A2E"/>
+                </a:solidFill>
+                <a:latin typeface="Calibri"/>
+              </a:rPr>
+              <a:t>Exports Excel et sauvegardes</a:t>
+            </a:r>
+          </a:p>
+        </p:txBody>
+      </p:sp>
+      <p:sp>
+        <p:nvSpPr>
+          <p:cNvPr id="44" name="Oval 43"/>
+          <p:cNvSpPr/>
+          <p:nvPr/>
+        </p:nvSpPr>
+        <p:spPr>
+          <a:xfrm>
+            <a:off x="8275320" y="5632704"/>
+            <a:ext cx="201168" cy="201168"/>
+          </a:xfrm>
+          <a:prstGeom prst="ellipse">
+            <a:avLst/>
+          </a:prstGeom>
+          <a:solidFill>
+            <a:srgbClr val="7B2FBE"/>
+          </a:solidFill>
+          <a:ln>
+            <a:noFill/>
+          </a:ln>
+          <a:effectLst/>
+        </p:spPr>
+        <p:style>
+          <a:lnRef idx="1">
+            <a:schemeClr val="accent1"/>
+          </a:lnRef>
+          <a:fillRef idx="3">
+            <a:schemeClr val="accent1"/>
+          </a:fillRef>
+          <a:effectRef idx="2">
+            <a:schemeClr val="accent1"/>
+          </a:effectRef>
+          <a:fontRef idx="minor">
+            <a:schemeClr val="lt1"/>
+          </a:fontRef>
+        </p:style>
+        <p:txBody>
+          <a:bodyPr rtlCol="0" anchor="ctr" lIns="0" rIns="0" tIns="0" bIns="0"/>
+          <a:lstStyle/>
+          <a:p>
+            <a:pPr algn="ctr"/>
+            <a:r>
+              <a:rPr sz="900" b="1">
+                <a:solidFill>
+                  <a:srgbClr val="FFFFFF"/>
+                </a:solidFill>
+                <a:latin typeface="Calibri"/>
+              </a:rPr>
+              <a:t/>
+            </a:r>
+          </a:p>
+        </p:txBody>
+      </p:sp>
+      <p:sp>
+        <p:nvSpPr>
+          <p:cNvPr id="45" name="TextBox 44"/>
+          <p:cNvSpPr txBox="1"/>
+          <p:nvPr/>
+        </p:nvSpPr>
+        <p:spPr>
+          <a:xfrm>
+            <a:off x="8622792" y="5559552"/>
+            <a:ext cx="2624328" cy="566928"/>
+          </a:xfrm>
+          <a:prstGeom prst="rect">
+            <a:avLst/>
+          </a:prstGeom>
+          <a:noFill/>
+        </p:spPr>
+        <p:txBody>
+          <a:bodyPr wrap="square" lIns="0" rIns="0" tIns="0" bIns="0" anchor="t">
+            <a:spAutoFit/>
+          </a:bodyPr>
+          <a:lstStyle/>
+          <a:p>
+            <a:pPr algn="l">
+              <a:lnSpc>
+                <a:spcPct val="115000"/>
+              </a:lnSpc>
+              <a:spcAft>
+                <a:spcPts val="600"/>
+              </a:spcAft>
+            </a:pPr>
+            <a:r>
+              <a:rPr sz="1350" b="0">
                 <a:solidFill>
                   <a:srgbClr val="2D3A2E"/>
                 </a:solidFill>

</xml_diff>

<commit_message>
Agent autonome sur le parcours client, sans accès au chiffre d'affaires
L'agent d'accueil enchaîne seul inscription, carte, encaissement au prix
catalogue avec reçu, puis validation de l'entrée. Les revenus (page
Paiements, tableau de bord) redeviennent réservés au gérant, et un reçu
n'est consultable que par l'employé qui l'a encaissé — plus possible de
lire les montants des autres en devinant un numéro de reçu.

Co-Authored-By: Claude Fable 5 <noreply@anthropic.com>
</commit_message>
<xml_diff>
--- a/formation/Didikids_Parc_Formation_Employes.pptx
+++ b/formation/Didikids_Parc_Formation_Employes.pptx
@@ -7775,7 +7775,7 @@
                 </a:solidFill>
                 <a:latin typeface="Calibri"/>
               </a:rPr>
-              <a:t>Vendre au prix du catalogue</a:t>
+              <a:t>Encaisser au prix du catalogue</a:t>
             </a:r>
           </a:p>
         </p:txBody>
@@ -7870,7 +7870,7 @@
                 </a:solidFill>
                 <a:latin typeface="Calibri"/>
               </a:rPr>
-              <a:t>Voir les paiements, réimprimer un reçu</a:t>
+              <a:t>Imprimer le reçu de sa vente</a:t>
             </a:r>
           </a:p>
         </p:txBody>
@@ -8288,7 +8288,7 @@
                 </a:solidFill>
                 <a:latin typeface="Calibri"/>
               </a:rPr>
-              <a:t>Voir le tableau de bord</a:t>
+              <a:t>Voir les paiements du parc</a:t>
             </a:r>
           </a:p>
         </p:txBody>

</xml_diff>